<commit_message>
added gitignore and added solutions folder
</commit_message>
<xml_diff>
--- a/Lectures/Chunk1.pptx
+++ b/Lectures/Chunk1.pptx
@@ -6,6 +6,10 @@
   </p:sldMasterIdLst>
   <p:sldIdLst>
     <p:sldId id="256" r:id="rId2"/>
+    <p:sldId id="257" r:id="rId3"/>
+    <p:sldId id="258" r:id="rId4"/>
+    <p:sldId id="260" r:id="rId5"/>
+    <p:sldId id="259" r:id="rId6"/>
   </p:sldIdLst>
   <p:sldSz cx="12192000" cy="6858000"/>
   <p:notesSz cx="6858000" cy="9144000"/>
@@ -104,23 +108,144 @@
       </a:defRPr>
     </a:lvl9pPr>
   </p:defaultTextStyle>
+  <p:extLst>
+    <p:ext uri="{EFAFB233-063F-42B5-8137-9DF3F51BA10A}">
+      <p15:sldGuideLst xmlns:p15="http://schemas.microsoft.com/office/powerpoint/2012/main"/>
+    </p:ext>
+  </p:extLst>
 </p:presentation>
+</file>
+
+<file path=ppt/revisionInfo.xml><?xml version="1.0" encoding="utf-8"?>
+<p1510:revInfo xmlns:a="http://schemas.openxmlformats.org/drawingml/2006/main" xmlns:r="http://schemas.openxmlformats.org/officeDocument/2006/relationships" xmlns:p1510="http://schemas.microsoft.com/office/powerpoint/2015/10/main">
+  <p1510:revLst>
+    <p1510:client id="{B108959E-8160-4214-BA0D-42D2F1070C03}" v="2" dt="2025-08-17T14:49:31.319"/>
+  </p1510:revLst>
+</p1510:revInfo>
 </file>
 
 <file path=ppt/changesInfos/changesInfo1.xml><?xml version="1.0" encoding="utf-8"?>
 <pc:chgInfo xmlns:a="http://schemas.openxmlformats.org/drawingml/2006/main" xmlns:r="http://schemas.openxmlformats.org/officeDocument/2006/relationships" xmlns:ac="http://schemas.microsoft.com/office/drawing/2013/main/command" xmlns:pc="http://schemas.microsoft.com/office/powerpoint/2013/main/command">
   <pc:docChgLst>
     <pc:chgData name="Jonathan Bollig" userId="8b5d0afe-f106-45e0-8c3f-fd98fa124db1" providerId="ADAL" clId="{B108959E-8160-4214-BA0D-42D2F1070C03}"/>
-    <pc:docChg chg="addSld">
-      <pc:chgData name="Jonathan Bollig" userId="8b5d0afe-f106-45e0-8c3f-fd98fa124db1" providerId="ADAL" clId="{B108959E-8160-4214-BA0D-42D2F1070C03}" dt="2025-08-17T13:50:52.306" v="0" actId="680"/>
+    <pc:docChg chg="custSel addSld modSld">
+      <pc:chgData name="Jonathan Bollig" userId="8b5d0afe-f106-45e0-8c3f-fd98fa124db1" providerId="ADAL" clId="{B108959E-8160-4214-BA0D-42D2F1070C03}" dt="2025-08-17T16:09:25.356" v="1734" actId="20577"/>
       <pc:docMkLst>
         <pc:docMk/>
       </pc:docMkLst>
-      <pc:sldChg chg="new">
-        <pc:chgData name="Jonathan Bollig" userId="8b5d0afe-f106-45e0-8c3f-fd98fa124db1" providerId="ADAL" clId="{B108959E-8160-4214-BA0D-42D2F1070C03}" dt="2025-08-17T13:50:52.306" v="0" actId="680"/>
+      <pc:sldChg chg="modSp new mod">
+        <pc:chgData name="Jonathan Bollig" userId="8b5d0afe-f106-45e0-8c3f-fd98fa124db1" providerId="ADAL" clId="{B108959E-8160-4214-BA0D-42D2F1070C03}" dt="2025-08-17T14:49:54.498" v="725" actId="20577"/>
         <pc:sldMkLst>
           <pc:docMk/>
           <pc:sldMk cId="836289018" sldId="256"/>
+        </pc:sldMkLst>
+        <pc:spChg chg="mod">
+          <ac:chgData name="Jonathan Bollig" userId="8b5d0afe-f106-45e0-8c3f-fd98fa124db1" providerId="ADAL" clId="{B108959E-8160-4214-BA0D-42D2F1070C03}" dt="2025-08-17T14:49:39.923" v="714" actId="20577"/>
+          <ac:spMkLst>
+            <pc:docMk/>
+            <pc:sldMk cId="836289018" sldId="256"/>
+            <ac:spMk id="2" creationId="{40F72F59-52B3-6063-A2E3-2AA45125A99B}"/>
+          </ac:spMkLst>
+        </pc:spChg>
+        <pc:spChg chg="mod">
+          <ac:chgData name="Jonathan Bollig" userId="8b5d0afe-f106-45e0-8c3f-fd98fa124db1" providerId="ADAL" clId="{B108959E-8160-4214-BA0D-42D2F1070C03}" dt="2025-08-17T14:49:54.498" v="725" actId="20577"/>
+          <ac:spMkLst>
+            <pc:docMk/>
+            <pc:sldMk cId="836289018" sldId="256"/>
+            <ac:spMk id="3" creationId="{62F76653-44B5-8707-B179-FDB90CB514B7}"/>
+          </ac:spMkLst>
+        </pc:spChg>
+      </pc:sldChg>
+      <pc:sldChg chg="modSp new mod">
+        <pc:chgData name="Jonathan Bollig" userId="8b5d0afe-f106-45e0-8c3f-fd98fa124db1" providerId="ADAL" clId="{B108959E-8160-4214-BA0D-42D2F1070C03}" dt="2025-08-17T16:08:13.844" v="1626" actId="20577"/>
+        <pc:sldMkLst>
+          <pc:docMk/>
+          <pc:sldMk cId="3656329933" sldId="257"/>
+        </pc:sldMkLst>
+        <pc:spChg chg="mod">
+          <ac:chgData name="Jonathan Bollig" userId="8b5d0afe-f106-45e0-8c3f-fd98fa124db1" providerId="ADAL" clId="{B108959E-8160-4214-BA0D-42D2F1070C03}" dt="2025-08-17T16:08:13.844" v="1626" actId="20577"/>
+          <ac:spMkLst>
+            <pc:docMk/>
+            <pc:sldMk cId="3656329933" sldId="257"/>
+            <ac:spMk id="2" creationId="{12CD386F-59C6-F67B-7DCD-F1BC663E3B72}"/>
+          </ac:spMkLst>
+        </pc:spChg>
+        <pc:spChg chg="mod">
+          <ac:chgData name="Jonathan Bollig" userId="8b5d0afe-f106-45e0-8c3f-fd98fa124db1" providerId="ADAL" clId="{B108959E-8160-4214-BA0D-42D2F1070C03}" dt="2025-08-17T14:47:57.676" v="647" actId="20577"/>
+          <ac:spMkLst>
+            <pc:docMk/>
+            <pc:sldMk cId="3656329933" sldId="257"/>
+            <ac:spMk id="3" creationId="{916BD547-131A-7854-8F80-981FAD9C3A75}"/>
+          </ac:spMkLst>
+        </pc:spChg>
+      </pc:sldChg>
+      <pc:sldChg chg="addSp delSp modSp new mod">
+        <pc:chgData name="Jonathan Bollig" userId="8b5d0afe-f106-45e0-8c3f-fd98fa124db1" providerId="ADAL" clId="{B108959E-8160-4214-BA0D-42D2F1070C03}" dt="2025-08-17T16:09:25.356" v="1734" actId="20577"/>
+        <pc:sldMkLst>
+          <pc:docMk/>
+          <pc:sldMk cId="544279955" sldId="258"/>
+        </pc:sldMkLst>
+        <pc:spChg chg="mod">
+          <ac:chgData name="Jonathan Bollig" userId="8b5d0afe-f106-45e0-8c3f-fd98fa124db1" providerId="ADAL" clId="{B108959E-8160-4214-BA0D-42D2F1070C03}" dt="2025-08-17T16:08:08.668" v="1618" actId="20577"/>
+          <ac:spMkLst>
+            <pc:docMk/>
+            <pc:sldMk cId="544279955" sldId="258"/>
+            <ac:spMk id="2" creationId="{39CEC020-67CE-83BA-52A4-53DB4E738D1E}"/>
+          </ac:spMkLst>
+        </pc:spChg>
+        <pc:spChg chg="mod">
+          <ac:chgData name="Jonathan Bollig" userId="8b5d0afe-f106-45e0-8c3f-fd98fa124db1" providerId="ADAL" clId="{B108959E-8160-4214-BA0D-42D2F1070C03}" dt="2025-08-17T16:09:25.356" v="1734" actId="20577"/>
+          <ac:spMkLst>
+            <pc:docMk/>
+            <pc:sldMk cId="544279955" sldId="258"/>
+            <ac:spMk id="3" creationId="{A2763ED7-8DD3-93DC-2F3B-D6B7FEB3B367}"/>
+          </ac:spMkLst>
+        </pc:spChg>
+        <pc:picChg chg="add del mod">
+          <ac:chgData name="Jonathan Bollig" userId="8b5d0afe-f106-45e0-8c3f-fd98fa124db1" providerId="ADAL" clId="{B108959E-8160-4214-BA0D-42D2F1070C03}" dt="2025-08-17T15:57:39.699" v="1541" actId="478"/>
+          <ac:picMkLst>
+            <pc:docMk/>
+            <pc:sldMk cId="544279955" sldId="258"/>
+            <ac:picMk id="5" creationId="{9FC64D72-24A1-5A97-E437-48787B15B862}"/>
+          </ac:picMkLst>
+        </pc:picChg>
+        <pc:picChg chg="add mod">
+          <ac:chgData name="Jonathan Bollig" userId="8b5d0afe-f106-45e0-8c3f-fd98fa124db1" providerId="ADAL" clId="{B108959E-8160-4214-BA0D-42D2F1070C03}" dt="2025-08-17T15:59:27.122" v="1579" actId="1440"/>
+          <ac:picMkLst>
+            <pc:docMk/>
+            <pc:sldMk cId="544279955" sldId="258"/>
+            <ac:picMk id="7" creationId="{E1D75445-F62B-736D-2C1E-98F04E1BC60E}"/>
+          </ac:picMkLst>
+        </pc:picChg>
+      </pc:sldChg>
+      <pc:sldChg chg="modSp new mod">
+        <pc:chgData name="Jonathan Bollig" userId="8b5d0afe-f106-45e0-8c3f-fd98fa124db1" providerId="ADAL" clId="{B108959E-8160-4214-BA0D-42D2F1070C03}" dt="2025-08-17T15:01:30.527" v="1536" actId="20577"/>
+        <pc:sldMkLst>
+          <pc:docMk/>
+          <pc:sldMk cId="2169503629" sldId="259"/>
+        </pc:sldMkLst>
+        <pc:spChg chg="mod">
+          <ac:chgData name="Jonathan Bollig" userId="8b5d0afe-f106-45e0-8c3f-fd98fa124db1" providerId="ADAL" clId="{B108959E-8160-4214-BA0D-42D2F1070C03}" dt="2025-08-17T14:57:58.468" v="1466" actId="20577"/>
+          <ac:spMkLst>
+            <pc:docMk/>
+            <pc:sldMk cId="2169503629" sldId="259"/>
+            <ac:spMk id="2" creationId="{6F7A0B5F-607C-4C36-ECF8-BBF9DF9AD9EA}"/>
+          </ac:spMkLst>
+        </pc:spChg>
+        <pc:spChg chg="mod">
+          <ac:chgData name="Jonathan Bollig" userId="8b5d0afe-f106-45e0-8c3f-fd98fa124db1" providerId="ADAL" clId="{B108959E-8160-4214-BA0D-42D2F1070C03}" dt="2025-08-17T15:01:30.527" v="1536" actId="20577"/>
+          <ac:spMkLst>
+            <pc:docMk/>
+            <pc:sldMk cId="2169503629" sldId="259"/>
+            <ac:spMk id="3" creationId="{90A723FE-AE4A-BC31-F8DA-B479D4E846FF}"/>
+          </ac:spMkLst>
+        </pc:spChg>
+      </pc:sldChg>
+      <pc:sldChg chg="new">
+        <pc:chgData name="Jonathan Bollig" userId="8b5d0afe-f106-45e0-8c3f-fd98fa124db1" providerId="ADAL" clId="{B108959E-8160-4214-BA0D-42D2F1070C03}" dt="2025-08-17T14:55:19.056" v="1223" actId="680"/>
+        <pc:sldMkLst>
+          <pc:docMk/>
+          <pc:sldMk cId="2533283895" sldId="260"/>
         </pc:sldMkLst>
       </pc:sldChg>
     </pc:docChg>
@@ -3363,7 +3488,18 @@
           <a:bodyPr/>
           <a:lstStyle/>
           <a:p>
-            <a:endParaRPr lang="de-DE"/>
+            <a:r>
+              <a:rPr lang="en-US" dirty="0"/>
+              <a:t>Python Course for Physicists</a:t>
+            </a:r>
+            <a:br>
+              <a:rPr lang="en-US" dirty="0"/>
+            </a:br>
+            <a:r>
+              <a:rPr lang="en-US" dirty="0"/>
+              <a:t>– Chunk 1: Introduction</a:t>
+            </a:r>
+            <a:endParaRPr lang="de-DE" dirty="0"/>
           </a:p>
         </p:txBody>
       </p:sp>
@@ -3388,7 +3524,17 @@
           <a:bodyPr/>
           <a:lstStyle/>
           <a:p>
-            <a:endParaRPr lang="de-DE"/>
+            <a:r>
+              <a:rPr lang="en-US" dirty="0"/>
+              <a:t>By Jonathan Bollig</a:t>
+            </a:r>
+          </a:p>
+          <a:p>
+            <a:r>
+              <a:rPr lang="en-US" dirty="0"/>
+              <a:t>08.10.2025</a:t>
+            </a:r>
+            <a:endParaRPr lang="de-DE" dirty="0"/>
           </a:p>
         </p:txBody>
       </p:sp>
@@ -3396,6 +3542,579 @@
     <p:extLst>
       <p:ext uri="{BB962C8B-B14F-4D97-AF65-F5344CB8AC3E}">
         <p14:creationId xmlns:p14="http://schemas.microsoft.com/office/powerpoint/2010/main" val="836289018"/>
+      </p:ext>
+    </p:extLst>
+  </p:cSld>
+  <p:clrMapOvr>
+    <a:masterClrMapping/>
+  </p:clrMapOvr>
+</p:sld>
+</file>
+
+<file path=ppt/slides/slide2.xml><?xml version="1.0" encoding="utf-8"?>
+<p:sld xmlns:a="http://schemas.openxmlformats.org/drawingml/2006/main" xmlns:r="http://schemas.openxmlformats.org/officeDocument/2006/relationships" xmlns:p="http://schemas.openxmlformats.org/presentationml/2006/main">
+  <p:cSld>
+    <p:spTree>
+      <p:nvGrpSpPr>
+        <p:cNvPr id="1" name=""/>
+        <p:cNvGrpSpPr/>
+        <p:nvPr/>
+      </p:nvGrpSpPr>
+      <p:grpSpPr>
+        <a:xfrm>
+          <a:off x="0" y="0"/>
+          <a:ext cx="0" cy="0"/>
+          <a:chOff x="0" y="0"/>
+          <a:chExt cx="0" cy="0"/>
+        </a:xfrm>
+      </p:grpSpPr>
+      <p:sp>
+        <p:nvSpPr>
+          <p:cNvPr id="2" name="Titel 1">
+            <a:extLst>
+              <a:ext uri="{FF2B5EF4-FFF2-40B4-BE49-F238E27FC236}">
+                <a16:creationId xmlns:a16="http://schemas.microsoft.com/office/drawing/2014/main" id="{12CD386F-59C6-F67B-7DCD-F1BC663E3B72}"/>
+              </a:ext>
+            </a:extLst>
+          </p:cNvPr>
+          <p:cNvSpPr>
+            <a:spLocks noGrp="1"/>
+          </p:cNvSpPr>
+          <p:nvPr>
+            <p:ph type="title"/>
+          </p:nvPr>
+        </p:nvSpPr>
+        <p:spPr/>
+        <p:txBody>
+          <a:bodyPr/>
+          <a:lstStyle/>
+          <a:p>
+            <a:r>
+              <a:rPr lang="en-US" dirty="0"/>
+              <a:t>General Information – Times and Dates</a:t>
+            </a:r>
+            <a:endParaRPr lang="de-DE" dirty="0"/>
+          </a:p>
+        </p:txBody>
+      </p:sp>
+      <p:sp>
+        <p:nvSpPr>
+          <p:cNvPr id="3" name="Inhaltsplatzhalter 2">
+            <a:extLst>
+              <a:ext uri="{FF2B5EF4-FFF2-40B4-BE49-F238E27FC236}">
+                <a16:creationId xmlns:a16="http://schemas.microsoft.com/office/drawing/2014/main" id="{916BD547-131A-7854-8F80-981FAD9C3A75}"/>
+              </a:ext>
+            </a:extLst>
+          </p:cNvPr>
+          <p:cNvSpPr>
+            <a:spLocks noGrp="1"/>
+          </p:cNvSpPr>
+          <p:nvPr>
+            <p:ph idx="1"/>
+          </p:nvPr>
+        </p:nvSpPr>
+        <p:spPr/>
+        <p:txBody>
+          <a:bodyPr/>
+          <a:lstStyle/>
+          <a:p>
+            <a:r>
+              <a:rPr lang="en-US" dirty="0"/>
+              <a:t>Dates: </a:t>
+            </a:r>
+          </a:p>
+          <a:p>
+            <a:pPr lvl="1"/>
+            <a:r>
+              <a:rPr lang="en-US" dirty="0"/>
+              <a:t>Regular: Wednesday to Friday</a:t>
+            </a:r>
+          </a:p>
+          <a:p>
+            <a:pPr lvl="1"/>
+            <a:r>
+              <a:rPr lang="en-US" dirty="0"/>
+              <a:t>Maybe Saturday if delayed or for extra “chunks” (Improvised if demanded)</a:t>
+            </a:r>
+          </a:p>
+          <a:p>
+            <a:r>
+              <a:rPr lang="en-US" dirty="0"/>
+              <a:t>Times: </a:t>
+            </a:r>
+          </a:p>
+          <a:p>
+            <a:pPr lvl="1"/>
+            <a:r>
+              <a:rPr lang="en-US" dirty="0"/>
+              <a:t>Start at 09:30</a:t>
+            </a:r>
+          </a:p>
+          <a:p>
+            <a:pPr lvl="1"/>
+            <a:r>
+              <a:rPr lang="en-US" dirty="0"/>
+              <a:t>Lunchbreak 12:30 – 13:30</a:t>
+            </a:r>
+          </a:p>
+          <a:p>
+            <a:pPr lvl="1"/>
+            <a:r>
+              <a:rPr lang="en-US" dirty="0"/>
+              <a:t>Finish: ~16:30</a:t>
+            </a:r>
+          </a:p>
+          <a:p>
+            <a:r>
+              <a:rPr lang="en-US" dirty="0"/>
+              <a:t>Lecturing type:</a:t>
+            </a:r>
+          </a:p>
+          <a:p>
+            <a:pPr lvl="1"/>
+            <a:r>
+              <a:rPr lang="en-US" dirty="0"/>
+              <a:t>15-minute lectures (Chunks) with 45-minute practice sessions</a:t>
+            </a:r>
+          </a:p>
+          <a:p>
+            <a:pPr lvl="1"/>
+            <a:r>
+              <a:rPr lang="en-US" dirty="0"/>
+              <a:t>3 chunks before and 3 after lunch </a:t>
+            </a:r>
+            <a:r>
+              <a:rPr lang="en-US" dirty="0">
+                <a:sym typeface="Wingdings" panose="05000000000000000000" pitchFamily="2" charset="2"/>
+              </a:rPr>
+              <a:t> 18 chunks in total</a:t>
+            </a:r>
+            <a:endParaRPr lang="de-DE" dirty="0"/>
+          </a:p>
+        </p:txBody>
+      </p:sp>
+    </p:spTree>
+    <p:extLst>
+      <p:ext uri="{BB962C8B-B14F-4D97-AF65-F5344CB8AC3E}">
+        <p14:creationId xmlns:p14="http://schemas.microsoft.com/office/powerpoint/2010/main" val="3656329933"/>
+      </p:ext>
+    </p:extLst>
+  </p:cSld>
+  <p:clrMapOvr>
+    <a:masterClrMapping/>
+  </p:clrMapOvr>
+</p:sld>
+</file>
+
+<file path=ppt/slides/slide3.xml><?xml version="1.0" encoding="utf-8"?>
+<p:sld xmlns:a="http://schemas.openxmlformats.org/drawingml/2006/main" xmlns:r="http://schemas.openxmlformats.org/officeDocument/2006/relationships" xmlns:p="http://schemas.openxmlformats.org/presentationml/2006/main">
+  <p:cSld>
+    <p:spTree>
+      <p:nvGrpSpPr>
+        <p:cNvPr id="1" name=""/>
+        <p:cNvGrpSpPr/>
+        <p:nvPr/>
+      </p:nvGrpSpPr>
+      <p:grpSpPr>
+        <a:xfrm>
+          <a:off x="0" y="0"/>
+          <a:ext cx="0" cy="0"/>
+          <a:chOff x="0" y="0"/>
+          <a:chExt cx="0" cy="0"/>
+        </a:xfrm>
+      </p:grpSpPr>
+      <p:sp>
+        <p:nvSpPr>
+          <p:cNvPr id="2" name="Titel 1">
+            <a:extLst>
+              <a:ext uri="{FF2B5EF4-FFF2-40B4-BE49-F238E27FC236}">
+                <a16:creationId xmlns:a16="http://schemas.microsoft.com/office/drawing/2014/main" id="{39CEC020-67CE-83BA-52A4-53DB4E738D1E}"/>
+              </a:ext>
+            </a:extLst>
+          </p:cNvPr>
+          <p:cNvSpPr>
+            <a:spLocks noGrp="1"/>
+          </p:cNvSpPr>
+          <p:nvPr>
+            <p:ph type="title"/>
+          </p:nvPr>
+        </p:nvSpPr>
+        <p:spPr/>
+        <p:txBody>
+          <a:bodyPr/>
+          <a:lstStyle/>
+          <a:p>
+            <a:r>
+              <a:rPr lang="en-US" dirty="0"/>
+              <a:t>General Information – Lecturing Type</a:t>
+            </a:r>
+            <a:endParaRPr lang="de-DE" dirty="0"/>
+          </a:p>
+        </p:txBody>
+      </p:sp>
+      <p:sp>
+        <p:nvSpPr>
+          <p:cNvPr id="3" name="Inhaltsplatzhalter 2">
+            <a:extLst>
+              <a:ext uri="{FF2B5EF4-FFF2-40B4-BE49-F238E27FC236}">
+                <a16:creationId xmlns:a16="http://schemas.microsoft.com/office/drawing/2014/main" id="{A2763ED7-8DD3-93DC-2F3B-D6B7FEB3B367}"/>
+              </a:ext>
+            </a:extLst>
+          </p:cNvPr>
+          <p:cNvSpPr>
+            <a:spLocks noGrp="1"/>
+          </p:cNvSpPr>
+          <p:nvPr>
+            <p:ph idx="1"/>
+          </p:nvPr>
+        </p:nvSpPr>
+        <p:spPr>
+          <a:xfrm>
+            <a:off x="838200" y="1825624"/>
+            <a:ext cx="10515600" cy="4899787"/>
+          </a:xfrm>
+        </p:spPr>
+        <p:txBody>
+          <a:bodyPr>
+            <a:normAutofit/>
+          </a:bodyPr>
+          <a:lstStyle/>
+          <a:p>
+            <a:r>
+              <a:rPr lang="en-US" noProof="0" dirty="0"/>
+              <a:t>15 Minute Lectures: Concise introductions to topics (YT tutorial style)</a:t>
+            </a:r>
+          </a:p>
+          <a:p>
+            <a:pPr lvl="1"/>
+            <a:r>
+              <a:rPr lang="en-US" noProof="0" dirty="0"/>
+              <a:t>PDFs are uploaded</a:t>
+            </a:r>
+          </a:p>
+          <a:p>
+            <a:r>
+              <a:rPr lang="en-US" noProof="0" dirty="0"/>
+              <a:t>45 Minute self practice:</a:t>
+            </a:r>
+          </a:p>
+          <a:p>
+            <a:pPr lvl="1"/>
+            <a:r>
+              <a:rPr lang="en-US" noProof="0" dirty="0"/>
+              <a:t>Usage of </a:t>
+            </a:r>
+            <a:r>
+              <a:rPr lang="en-US" noProof="0" dirty="0" err="1"/>
+              <a:t>Jupyter</a:t>
+            </a:r>
+            <a:r>
+              <a:rPr lang="en-US" noProof="0" dirty="0"/>
+              <a:t> Notebooks: Tasks and solutions in one place.</a:t>
+            </a:r>
+          </a:p>
+          <a:p>
+            <a:pPr lvl="1"/>
+            <a:endParaRPr lang="en-US" noProof="0" dirty="0"/>
+          </a:p>
+          <a:p>
+            <a:pPr lvl="1"/>
+            <a:endParaRPr lang="en-US" noProof="0" dirty="0"/>
+          </a:p>
+          <a:p>
+            <a:pPr lvl="1"/>
+            <a:endParaRPr lang="en-US" noProof="0" dirty="0"/>
+          </a:p>
+          <a:p>
+            <a:pPr lvl="1"/>
+            <a:endParaRPr lang="en-US" noProof="0" dirty="0"/>
+          </a:p>
+          <a:p>
+            <a:pPr lvl="1"/>
+            <a:r>
+              <a:rPr lang="en-US" noProof="0" dirty="0"/>
+              <a:t>Cheat Sheet at the top</a:t>
+            </a:r>
+          </a:p>
+          <a:p>
+            <a:pPr lvl="1"/>
+            <a:r>
+              <a:rPr lang="en-US" noProof="0" dirty="0"/>
+              <a:t>Easy, medium and advanced tasks</a:t>
+            </a:r>
+          </a:p>
+        </p:txBody>
+      </p:sp>
+      <p:pic>
+        <p:nvPicPr>
+          <p:cNvPr id="7" name="Grafik 6">
+            <a:extLst>
+              <a:ext uri="{FF2B5EF4-FFF2-40B4-BE49-F238E27FC236}">
+                <a16:creationId xmlns:a16="http://schemas.microsoft.com/office/drawing/2014/main" id="{E1D75445-F62B-736D-2C1E-98F04E1BC60E}"/>
+              </a:ext>
+            </a:extLst>
+          </p:cNvPr>
+          <p:cNvPicPr>
+            <a:picLocks noChangeAspect="1"/>
+          </p:cNvPicPr>
+          <p:nvPr/>
+        </p:nvPicPr>
+        <p:blipFill>
+          <a:blip r:embed="rId2"/>
+          <a:stretch>
+            <a:fillRect/>
+          </a:stretch>
+        </p:blipFill>
+        <p:spPr>
+          <a:xfrm>
+            <a:off x="2990703" y="4005866"/>
+            <a:ext cx="4832559" cy="1479720"/>
+          </a:xfrm>
+          <a:prstGeom prst="rect">
+            <a:avLst/>
+          </a:prstGeom>
+          <a:ln>
+            <a:noFill/>
+          </a:ln>
+          <a:effectLst>
+            <a:outerShdw blurRad="292100" dist="139700" dir="2700000" algn="tl" rotWithShape="0">
+              <a:srgbClr val="333333">
+                <a:alpha val="65000"/>
+              </a:srgbClr>
+            </a:outerShdw>
+          </a:effectLst>
+        </p:spPr>
+      </p:pic>
+    </p:spTree>
+    <p:extLst>
+      <p:ext uri="{BB962C8B-B14F-4D97-AF65-F5344CB8AC3E}">
+        <p14:creationId xmlns:p14="http://schemas.microsoft.com/office/powerpoint/2010/main" val="544279955"/>
+      </p:ext>
+    </p:extLst>
+  </p:cSld>
+  <p:clrMapOvr>
+    <a:masterClrMapping/>
+  </p:clrMapOvr>
+</p:sld>
+</file>
+
+<file path=ppt/slides/slide4.xml><?xml version="1.0" encoding="utf-8"?>
+<p:sld xmlns:a="http://schemas.openxmlformats.org/drawingml/2006/main" xmlns:r="http://schemas.openxmlformats.org/officeDocument/2006/relationships" xmlns:p="http://schemas.openxmlformats.org/presentationml/2006/main">
+  <p:cSld>
+    <p:spTree>
+      <p:nvGrpSpPr>
+        <p:cNvPr id="1" name=""/>
+        <p:cNvGrpSpPr/>
+        <p:nvPr/>
+      </p:nvGrpSpPr>
+      <p:grpSpPr>
+        <a:xfrm>
+          <a:off x="0" y="0"/>
+          <a:ext cx="0" cy="0"/>
+          <a:chOff x="0" y="0"/>
+          <a:chExt cx="0" cy="0"/>
+        </a:xfrm>
+      </p:grpSpPr>
+      <p:sp>
+        <p:nvSpPr>
+          <p:cNvPr id="2" name="Titel 1">
+            <a:extLst>
+              <a:ext uri="{FF2B5EF4-FFF2-40B4-BE49-F238E27FC236}">
+                <a16:creationId xmlns:a16="http://schemas.microsoft.com/office/drawing/2014/main" id="{23925054-C76E-45A7-4239-2BA56785FD84}"/>
+              </a:ext>
+            </a:extLst>
+          </p:cNvPr>
+          <p:cNvSpPr>
+            <a:spLocks noGrp="1"/>
+          </p:cNvSpPr>
+          <p:nvPr>
+            <p:ph type="title"/>
+          </p:nvPr>
+        </p:nvSpPr>
+        <p:spPr/>
+        <p:txBody>
+          <a:bodyPr/>
+          <a:lstStyle/>
+          <a:p>
+            <a:endParaRPr lang="de-DE"/>
+          </a:p>
+        </p:txBody>
+      </p:sp>
+      <p:sp>
+        <p:nvSpPr>
+          <p:cNvPr id="3" name="Inhaltsplatzhalter 2">
+            <a:extLst>
+              <a:ext uri="{FF2B5EF4-FFF2-40B4-BE49-F238E27FC236}">
+                <a16:creationId xmlns:a16="http://schemas.microsoft.com/office/drawing/2014/main" id="{E7F7788F-7BB4-2420-6F85-726B9B09E4A6}"/>
+              </a:ext>
+            </a:extLst>
+          </p:cNvPr>
+          <p:cNvSpPr>
+            <a:spLocks noGrp="1"/>
+          </p:cNvSpPr>
+          <p:nvPr>
+            <p:ph idx="1"/>
+          </p:nvPr>
+        </p:nvSpPr>
+        <p:spPr/>
+        <p:txBody>
+          <a:bodyPr/>
+          <a:lstStyle/>
+          <a:p>
+            <a:endParaRPr lang="de-DE"/>
+          </a:p>
+        </p:txBody>
+      </p:sp>
+    </p:spTree>
+    <p:extLst>
+      <p:ext uri="{BB962C8B-B14F-4D97-AF65-F5344CB8AC3E}">
+        <p14:creationId xmlns:p14="http://schemas.microsoft.com/office/powerpoint/2010/main" val="2533283895"/>
+      </p:ext>
+    </p:extLst>
+  </p:cSld>
+  <p:clrMapOvr>
+    <a:masterClrMapping/>
+  </p:clrMapOvr>
+</p:sld>
+</file>
+
+<file path=ppt/slides/slide5.xml><?xml version="1.0" encoding="utf-8"?>
+<p:sld xmlns:a="http://schemas.openxmlformats.org/drawingml/2006/main" xmlns:r="http://schemas.openxmlformats.org/officeDocument/2006/relationships" xmlns:p="http://schemas.openxmlformats.org/presentationml/2006/main">
+  <p:cSld>
+    <p:spTree>
+      <p:nvGrpSpPr>
+        <p:cNvPr id="1" name=""/>
+        <p:cNvGrpSpPr/>
+        <p:nvPr/>
+      </p:nvGrpSpPr>
+      <p:grpSpPr>
+        <a:xfrm>
+          <a:off x="0" y="0"/>
+          <a:ext cx="0" cy="0"/>
+          <a:chOff x="0" y="0"/>
+          <a:chExt cx="0" cy="0"/>
+        </a:xfrm>
+      </p:grpSpPr>
+      <p:sp>
+        <p:nvSpPr>
+          <p:cNvPr id="2" name="Titel 1">
+            <a:extLst>
+              <a:ext uri="{FF2B5EF4-FFF2-40B4-BE49-F238E27FC236}">
+                <a16:creationId xmlns:a16="http://schemas.microsoft.com/office/drawing/2014/main" id="{6F7A0B5F-607C-4C36-ECF8-BBF9DF9AD9EA}"/>
+              </a:ext>
+            </a:extLst>
+          </p:cNvPr>
+          <p:cNvSpPr>
+            <a:spLocks noGrp="1"/>
+          </p:cNvSpPr>
+          <p:nvPr>
+            <p:ph type="title"/>
+          </p:nvPr>
+        </p:nvSpPr>
+        <p:spPr/>
+        <p:txBody>
+          <a:bodyPr/>
+          <a:lstStyle/>
+          <a:p>
+            <a:r>
+              <a:rPr lang="en-US" dirty="0"/>
+              <a:t>Some notes on solving task sheets	</a:t>
+            </a:r>
+            <a:endParaRPr lang="de-DE" dirty="0"/>
+          </a:p>
+        </p:txBody>
+      </p:sp>
+      <p:sp>
+        <p:nvSpPr>
+          <p:cNvPr id="3" name="Inhaltsplatzhalter 2">
+            <a:extLst>
+              <a:ext uri="{FF2B5EF4-FFF2-40B4-BE49-F238E27FC236}">
+                <a16:creationId xmlns:a16="http://schemas.microsoft.com/office/drawing/2014/main" id="{90A723FE-AE4A-BC31-F8DA-B479D4E846FF}"/>
+              </a:ext>
+            </a:extLst>
+          </p:cNvPr>
+          <p:cNvSpPr>
+            <a:spLocks noGrp="1"/>
+          </p:cNvSpPr>
+          <p:nvPr>
+            <p:ph idx="1"/>
+          </p:nvPr>
+        </p:nvSpPr>
+        <p:spPr/>
+        <p:txBody>
+          <a:bodyPr/>
+          <a:lstStyle/>
+          <a:p>
+            <a:r>
+              <a:rPr lang="en-US" dirty="0"/>
+              <a:t>Splitting into second room</a:t>
+            </a:r>
+          </a:p>
+          <a:p>
+            <a:r>
+              <a:rPr lang="en-US" dirty="0"/>
+              <a:t>How to go about solving task sheets</a:t>
+            </a:r>
+          </a:p>
+          <a:p>
+            <a:pPr lvl="1"/>
+            <a:r>
+              <a:rPr lang="en-US" dirty="0"/>
+              <a:t>Try yourself</a:t>
+            </a:r>
+          </a:p>
+          <a:p>
+            <a:pPr lvl="1"/>
+            <a:r>
+              <a:rPr lang="en-US" dirty="0"/>
+              <a:t>Ask google (</a:t>
+            </a:r>
+            <a:r>
+              <a:rPr lang="en-US" dirty="0" err="1"/>
+              <a:t>Stackoverflow</a:t>
+            </a:r>
+            <a:r>
+              <a:rPr lang="en-US" dirty="0"/>
+              <a:t> &lt;3) (google meme)</a:t>
+            </a:r>
+          </a:p>
+          <a:p>
+            <a:pPr lvl="1"/>
+            <a:r>
+              <a:rPr lang="en-US" dirty="0"/>
+              <a:t>Ask your neighbor (maybe before googling)</a:t>
+            </a:r>
+          </a:p>
+          <a:p>
+            <a:pPr lvl="1"/>
+            <a:r>
+              <a:rPr lang="en-US" dirty="0"/>
+              <a:t>Ask assistants</a:t>
+            </a:r>
+          </a:p>
+          <a:p>
+            <a:pPr lvl="1"/>
+            <a:r>
+              <a:rPr lang="en-US" dirty="0"/>
+              <a:t>(Maybe) ask LLM (ChatGPT / Perplexity / Copilot)</a:t>
+            </a:r>
+          </a:p>
+          <a:p>
+            <a:r>
+              <a:rPr lang="en-US" dirty="0"/>
+              <a:t>Struggling and debugging are 90% of a coders work</a:t>
+            </a:r>
+          </a:p>
+          <a:p>
+            <a:pPr lvl="1"/>
+            <a:endParaRPr lang="de-DE" dirty="0"/>
+          </a:p>
+        </p:txBody>
+      </p:sp>
+    </p:spTree>
+    <p:extLst>
+      <p:ext uri="{BB962C8B-B14F-4D97-AF65-F5344CB8AC3E}">
+        <p14:creationId xmlns:p14="http://schemas.microsoft.com/office/powerpoint/2010/main" val="2169503629"/>
       </p:ext>
     </p:extLst>
   </p:cSld>

</xml_diff>